<commit_message>
docs: refresh intranet access addresses (DHCP reassigned both NICs)
</commit_message>
<xml_diff>
--- a/docs/Meta2bAnalyst_group-meeting.pptx
+++ b/docs/Meta2bAnalyst_group-meeting.pptx
@@ -2389,7 +2389,7 @@
                 <a:ea typeface="Helvetica Neue" pitchFamily="34" charset="-122"/>
                 <a:cs typeface="Helvetica Neue" pitchFamily="34" charset="-120"/>
               </a:rPr>
-              <a:t>http://10.64.168.109</a:t>
+              <a:t>http://10.64.168.98</a:t>
             </a:r>
             <a:endParaRPr lang="en-US" sz="2200" dirty="0"/>
           </a:p>
@@ -2597,7 +2597,7 @@
                 <a:ea typeface="Helvetica Neue" pitchFamily="34" charset="-122"/>
                 <a:cs typeface="Helvetica Neue" pitchFamily="34" charset="-120"/>
               </a:rPr>
-              <a:t>http://10.64.168.109</a:t>
+              <a:t>http://10.64.168.98</a:t>
             </a:r>
             <a:endParaRPr lang="en-US" sz="4400" dirty="0"/>
           </a:p>
@@ -3769,7 +3769,7 @@
                 <a:ea typeface="Helvetica Neue" pitchFamily="34" charset="-122"/>
                 <a:cs typeface="Helvetica Neue" pitchFamily="34" charset="-120"/>
               </a:rPr>
-              <a:t>http://10.64.168.109</a:t>
+              <a:t>http://10.64.168.98</a:t>
             </a:r>
             <a:endParaRPr lang="en-US" sz="3000" dirty="0"/>
           </a:p>

</xml_diff>